<commit_message>
docs(submission): fill YouTube video link https://youtu.be/N7_jOGu725s (unlisted, verified live) into PPT slide 14 + regenerate PDF + sync SUBMISSION.md
</commit_message>
<xml_diff>
--- a/EmbedDesk-AI-Builder-Cup.pptx
+++ b/EmbedDesk-AI-Builder-Cup.pptx
@@ -355,7 +355,10 @@
         </p:spPr>
         <p:txBody>
           <a:bodyPr/>
-          <a:p/>
+          <a:p>
+            <a:pPr/>
+            <a:endParaRPr/>
+          </a:p>
         </p:txBody>
       </p:sp>
       <p:sp>
@@ -6996,7 +6999,7 @@
                 <a:cs typeface="Google Sans Flex Medium"/>
                 <a:sym typeface="Google Sans Flex Medium"/>
               </a:rPr>
-              <a:t>Demo Video Link (3 Minutes):   [ PASTE VIDEO URL AFTER UPLOAD ]   —  embeddesk-demo.mp4 (3 min 29 s, 1920×1080)</a:t>
+              <a:t>Demo Video Link (3 Minutes):   https://youtu.be/N7_jOGu725s   —  embeddesk-demo.mp4 (3 min 29 s, 1920×1080)</a:t>
             </a:r>
             <a:endParaRPr>
               <a:latin typeface="Google Sans Flex Medium"/>

</xml_diff>

<commit_message>
docs(submission): prototype live at embeddesk.web.app - backfill product link into PPT slide 14, regenerate PDF, sync SUBMISSION.md
- PPT P14 Final Product Link: https://embeddesk.web.app (Firebase Hosting + Render API), visually verified via slide export
- PDF regenerated via PowerPoint COM (16 pages, 0.82 MB, <= 5MB form limit)
- SUBMISSION.md: item 3 marked complete with live URLs + verification results;
  English brief rewritten to actual hybrid deployment (Hosting + Render, same
  serverless codebase also runs on Cloud Run / Cloud Functions), 997 chars
  (27-char margin under the 1024 form limit)
- Fixed first-line CR mangled to literal /r by edsdk set_text (known pitfall)
</commit_message>
<xml_diff>
--- a/EmbedDesk-AI-Builder-Cup.pptx
+++ b/EmbedDesk-AI-Builder-Cup.pptx
@@ -7025,8 +7025,25 @@
                 <a:cs typeface="Google Sans Flex Medium"/>
                 <a:sym typeface="Google Sans Flex Medium"/>
               </a:rPr>
-              <a:t>Final Product Link:   [ PASTE DEPLOYED PROTOTYPE URL AFTER DEPLOY ]</a:t>
+              <a:t>Final Product Link:   https://embeddesk.web.app   (Firebase Hosting + Render API)</a:t>
             </a:r>
+            <a:endParaRPr>
+              <a:latin typeface="Google Sans Flex Medium"/>
+              <a:ea typeface="Google Sans Flex Medium"/>
+              <a:cs typeface="Google Sans Flex Medium"/>
+              <a:sym typeface="Google Sans Flex Medium"/>
+            </a:endParaRPr>
+          </a:p>
+          <a:p>
+            <a:pPr marL="0" lvl="0" indent="0" algn="l" rtl="0">
+              <a:spcBef>
+                <a:spcPts val="0"/>
+              </a:spcBef>
+              <a:spcAft>
+                <a:spcPts val="0"/>
+              </a:spcAft>
+              <a:buNone/>
+            </a:pPr>
             <a:endParaRPr>
               <a:latin typeface="Google Sans Flex Medium"/>
               <a:ea typeface="Google Sans Flex Medium"/>

</xml_diff>